<commit_message>
fixed exec summary and presentation
</commit_message>
<xml_diff>
--- a/Mos_Presentation.pptx
+++ b/Mos_Presentation.pptx
@@ -117,6 +117,11 @@
       </a:defRPr>
     </a:lvl9pPr>
   </p:defaultTextStyle>
+  <p:extLst>
+    <p:ext uri="{EFAFB233-063F-42B5-8137-9DF3F51BA10A}">
+      <p15:sldGuideLst xmlns:p15="http://schemas.microsoft.com/office/powerpoint/2012/main"/>
+    </p:ext>
+  </p:extLst>
 </p:presentation>
 </file>
 
@@ -259,7 +264,7 @@
           <a:p>
             <a:fld id="{846CE7D5-CF57-46EF-B807-FDD0502418D4}" type="datetimeFigureOut">
               <a:rPr lang="en-US" smtClean="0"/>
-              <a:t>4/26/2026</a:t>
+              <a:t>4/27/2026</a:t>
             </a:fld>
             <a:endParaRPr lang="en-US"/>
           </a:p>
@@ -427,7 +432,7 @@
           <a:p>
             <a:fld id="{846CE7D5-CF57-46EF-B807-FDD0502418D4}" type="datetimeFigureOut">
               <a:rPr lang="en-US" smtClean="0"/>
-              <a:t>4/26/2026</a:t>
+              <a:t>4/27/2026</a:t>
             </a:fld>
             <a:endParaRPr lang="en-US"/>
           </a:p>
@@ -605,7 +610,7 @@
           <a:p>
             <a:fld id="{846CE7D5-CF57-46EF-B807-FDD0502418D4}" type="datetimeFigureOut">
               <a:rPr lang="en-US" smtClean="0"/>
-              <a:t>4/26/2026</a:t>
+              <a:t>4/27/2026</a:t>
             </a:fld>
             <a:endParaRPr lang="en-US"/>
           </a:p>
@@ -773,7 +778,7 @@
           <a:p>
             <a:fld id="{846CE7D5-CF57-46EF-B807-FDD0502418D4}" type="datetimeFigureOut">
               <a:rPr lang="en-US" smtClean="0"/>
-              <a:t>4/26/2026</a:t>
+              <a:t>4/27/2026</a:t>
             </a:fld>
             <a:endParaRPr lang="en-US"/>
           </a:p>
@@ -1018,7 +1023,7 @@
           <a:p>
             <a:fld id="{846CE7D5-CF57-46EF-B807-FDD0502418D4}" type="datetimeFigureOut">
               <a:rPr lang="en-US" smtClean="0"/>
-              <a:t>4/26/2026</a:t>
+              <a:t>4/27/2026</a:t>
             </a:fld>
             <a:endParaRPr lang="en-US"/>
           </a:p>
@@ -1247,7 +1252,7 @@
           <a:p>
             <a:fld id="{846CE7D5-CF57-46EF-B807-FDD0502418D4}" type="datetimeFigureOut">
               <a:rPr lang="en-US" smtClean="0"/>
-              <a:t>4/26/2026</a:t>
+              <a:t>4/27/2026</a:t>
             </a:fld>
             <a:endParaRPr lang="en-US"/>
           </a:p>
@@ -1611,7 +1616,7 @@
           <a:p>
             <a:fld id="{846CE7D5-CF57-46EF-B807-FDD0502418D4}" type="datetimeFigureOut">
               <a:rPr lang="en-US" smtClean="0"/>
-              <a:t>4/26/2026</a:t>
+              <a:t>4/27/2026</a:t>
             </a:fld>
             <a:endParaRPr lang="en-US"/>
           </a:p>
@@ -1728,7 +1733,7 @@
           <a:p>
             <a:fld id="{846CE7D5-CF57-46EF-B807-FDD0502418D4}" type="datetimeFigureOut">
               <a:rPr lang="en-US" smtClean="0"/>
-              <a:t>4/26/2026</a:t>
+              <a:t>4/27/2026</a:t>
             </a:fld>
             <a:endParaRPr lang="en-US"/>
           </a:p>
@@ -1823,7 +1828,7 @@
           <a:p>
             <a:fld id="{846CE7D5-CF57-46EF-B807-FDD0502418D4}" type="datetimeFigureOut">
               <a:rPr lang="en-US" smtClean="0"/>
-              <a:t>4/26/2026</a:t>
+              <a:t>4/27/2026</a:t>
             </a:fld>
             <a:endParaRPr lang="en-US"/>
           </a:p>
@@ -2098,7 +2103,7 @@
           <a:p>
             <a:fld id="{846CE7D5-CF57-46EF-B807-FDD0502418D4}" type="datetimeFigureOut">
               <a:rPr lang="en-US" smtClean="0"/>
-              <a:t>4/26/2026</a:t>
+              <a:t>4/27/2026</a:t>
             </a:fld>
             <a:endParaRPr lang="en-US"/>
           </a:p>
@@ -2353,7 +2358,7 @@
           <a:p>
             <a:fld id="{846CE7D5-CF57-46EF-B807-FDD0502418D4}" type="datetimeFigureOut">
               <a:rPr lang="en-US" smtClean="0"/>
-              <a:t>4/26/2026</a:t>
+              <a:t>4/27/2026</a:t>
             </a:fld>
             <a:endParaRPr lang="en-US"/>
           </a:p>
@@ -2564,7 +2569,7 @@
           <a:p>
             <a:fld id="{846CE7D5-CF57-46EF-B807-FDD0502418D4}" type="datetimeFigureOut">
               <a:rPr lang="en-US" smtClean="0"/>
-              <a:t>4/26/2026</a:t>
+              <a:t>4/27/2026</a:t>
             </a:fld>
             <a:endParaRPr lang="en-US"/>
           </a:p>
@@ -6022,7 +6027,7 @@
             </a:pPr>
             <a:r>
               <a:rPr lang="en-US" dirty="0"/>
-              <a:t>Can compute operations like max, min, and mode, unlike Segment trees </a:t>
+              <a:t>Can compute operations like max, min, and mode, unlike Fenwick trees </a:t>
             </a:r>
             <a:r>
               <a:rPr lang="en-US" dirty="0">
@@ -6033,7 +6038,7 @@
                   <a:srgbClr val="000080"/>
                 </a:highlight>
               </a:rPr>
-              <a:t>(Segment trees suck)</a:t>
+              <a:t>(and Segment trees suck)</a:t>
             </a:r>
           </a:p>
           <a:p>
@@ -8289,53 +8294,6 @@
           </a:p>
         </p:txBody>
       </p:sp>
-      <p:pic>
-        <p:nvPicPr>
-          <p:cNvPr id="4098" name="Picture 2" descr="Rustacean.net: Home of Ferris the Crab">
-            <a:extLst>
-              <a:ext uri="{FF2B5EF4-FFF2-40B4-BE49-F238E27FC236}">
-                <a16:creationId xmlns:a16="http://schemas.microsoft.com/office/drawing/2014/main" id="{540E5672-3979-C03D-1123-DE3E92F618D6}"/>
-              </a:ext>
-            </a:extLst>
-          </p:cNvPr>
-          <p:cNvPicPr>
-            <a:picLocks noChangeAspect="1" noChangeArrowheads="1"/>
-          </p:cNvPicPr>
-          <p:nvPr/>
-        </p:nvPicPr>
-        <p:blipFill>
-          <a:blip r:embed="rId3">
-            <a:extLst>
-              <a:ext uri="{28A0092B-C50C-407E-A947-70E740481C1C}">
-                <a14:useLocalDpi xmlns:a14="http://schemas.microsoft.com/office/drawing/2010/main" val="0"/>
-              </a:ext>
-            </a:extLst>
-          </a:blip>
-          <a:srcRect/>
-          <a:stretch>
-            <a:fillRect/>
-          </a:stretch>
-        </p:blipFill>
-        <p:spPr bwMode="auto">
-          <a:xfrm>
-            <a:off x="8561867" y="5165205"/>
-            <a:ext cx="2040297" cy="1361676"/>
-          </a:xfrm>
-          <a:prstGeom prst="rect">
-            <a:avLst/>
-          </a:prstGeom>
-          <a:noFill/>
-          <a:extLst>
-            <a:ext uri="{909E8E84-426E-40DD-AFC4-6F175D3DCCD1}">
-              <a14:hiddenFill xmlns:a14="http://schemas.microsoft.com/office/drawing/2010/main">
-                <a:solidFill>
-                  <a:srgbClr val="FFFFFF"/>
-                </a:solidFill>
-              </a14:hiddenFill>
-            </a:ext>
-          </a:extLst>
-        </p:spPr>
-      </p:pic>
     </p:spTree>
     <p:extLst>
       <p:ext uri="{BB962C8B-B14F-4D97-AF65-F5344CB8AC3E}">
@@ -8874,6 +8832,92 @@
           </a:graphicData>
         </a:graphic>
       </p:graphicFrame>
+      <p:pic>
+        <p:nvPicPr>
+          <p:cNvPr id="4098" name="Picture 2" descr="Rustacean.net: Home of Ferris the Crab">
+            <a:extLst>
+              <a:ext uri="{FF2B5EF4-FFF2-40B4-BE49-F238E27FC236}">
+                <a16:creationId xmlns:a16="http://schemas.microsoft.com/office/drawing/2014/main" id="{540E5672-3979-C03D-1123-DE3E92F618D6}"/>
+              </a:ext>
+            </a:extLst>
+          </p:cNvPr>
+          <p:cNvPicPr>
+            <a:picLocks noChangeAspect="1" noChangeArrowheads="1"/>
+          </p:cNvPicPr>
+          <p:nvPr/>
+        </p:nvPicPr>
+        <p:blipFill>
+          <a:blip r:embed="rId2">
+            <a:extLst>
+              <a:ext uri="{28A0092B-C50C-407E-A947-70E740481C1C}">
+                <a14:useLocalDpi xmlns:a14="http://schemas.microsoft.com/office/drawing/2010/main" val="0"/>
+              </a:ext>
+            </a:extLst>
+          </a:blip>
+          <a:srcRect/>
+          <a:stretch>
+            <a:fillRect/>
+          </a:stretch>
+        </p:blipFill>
+        <p:spPr bwMode="auto">
+          <a:xfrm>
+            <a:off x="10047767" y="5209353"/>
+            <a:ext cx="2040297" cy="1361676"/>
+          </a:xfrm>
+          <a:prstGeom prst="rect">
+            <a:avLst/>
+          </a:prstGeom>
+          <a:noFill/>
+          <a:extLst>
+            <a:ext uri="{909E8E84-426E-40DD-AFC4-6F175D3DCCD1}">
+              <a14:hiddenFill xmlns:a14="http://schemas.microsoft.com/office/drawing/2010/main">
+                <a:solidFill>
+                  <a:srgbClr val="FFFFFF"/>
+                </a:solidFill>
+              </a14:hiddenFill>
+            </a:ext>
+          </a:extLst>
+        </p:spPr>
+      </p:pic>
+      <p:sp>
+        <p:nvSpPr>
+          <p:cNvPr id="6" name="TextBox 5">
+            <a:extLst>
+              <a:ext uri="{FF2B5EF4-FFF2-40B4-BE49-F238E27FC236}">
+                <a16:creationId xmlns:a16="http://schemas.microsoft.com/office/drawing/2014/main" id="{ECC01E0C-92C0-A4E4-BCD3-EBFB15F38C14}"/>
+              </a:ext>
+            </a:extLst>
+          </p:cNvPr>
+          <p:cNvSpPr txBox="1"/>
+          <p:nvPr/>
+        </p:nvSpPr>
+        <p:spPr>
+          <a:xfrm>
+            <a:off x="10805746" y="6488239"/>
+            <a:ext cx="1666875" cy="369332"/>
+          </a:xfrm>
+          <a:prstGeom prst="rect">
+            <a:avLst/>
+          </a:prstGeom>
+          <a:noFill/>
+        </p:spPr>
+        <p:txBody>
+          <a:bodyPr wrap="square" rtlCol="0">
+            <a:spAutoFit/>
+          </a:bodyPr>
+          <a:lstStyle/>
+          <a:p>
+            <a:r>
+              <a:rPr lang="en-US" dirty="0">
+                <a:solidFill>
+                  <a:schemeClr val="bg1"/>
+                </a:solidFill>
+              </a:rPr>
+              <a:t>Ferris</a:t>
+            </a:r>
+          </a:p>
+        </p:txBody>
+      </p:sp>
     </p:spTree>
     <p:extLst>
       <p:ext uri="{BB962C8B-B14F-4D97-AF65-F5344CB8AC3E}">
@@ -9460,6 +9504,92 @@
             <a:r>
               <a:rPr lang="en-US"/>
               <a:t>Ru(mo)nthrough</a:t>
+            </a:r>
+          </a:p>
+        </p:txBody>
+      </p:sp>
+      <p:pic>
+        <p:nvPicPr>
+          <p:cNvPr id="11" name="Picture 2" descr="Rustacean.net: Home of Ferris the Crab">
+            <a:extLst>
+              <a:ext uri="{FF2B5EF4-FFF2-40B4-BE49-F238E27FC236}">
+                <a16:creationId xmlns:a16="http://schemas.microsoft.com/office/drawing/2014/main" id="{8FF06745-9E99-2F62-1900-BFE85E2B1151}"/>
+              </a:ext>
+            </a:extLst>
+          </p:cNvPr>
+          <p:cNvPicPr>
+            <a:picLocks noChangeAspect="1" noChangeArrowheads="1"/>
+          </p:cNvPicPr>
+          <p:nvPr/>
+        </p:nvPicPr>
+        <p:blipFill>
+          <a:blip r:embed="rId2">
+            <a:extLst>
+              <a:ext uri="{28A0092B-C50C-407E-A947-70E740481C1C}">
+                <a14:useLocalDpi xmlns:a14="http://schemas.microsoft.com/office/drawing/2010/main" val="0"/>
+              </a:ext>
+            </a:extLst>
+          </a:blip>
+          <a:srcRect/>
+          <a:stretch>
+            <a:fillRect/>
+          </a:stretch>
+        </p:blipFill>
+        <p:spPr bwMode="auto">
+          <a:xfrm>
+            <a:off x="8771417" y="5209353"/>
+            <a:ext cx="2040297" cy="1361676"/>
+          </a:xfrm>
+          <a:prstGeom prst="rect">
+            <a:avLst/>
+          </a:prstGeom>
+          <a:noFill/>
+          <a:extLst>
+            <a:ext uri="{909E8E84-426E-40DD-AFC4-6F175D3DCCD1}">
+              <a14:hiddenFill xmlns:a14="http://schemas.microsoft.com/office/drawing/2010/main">
+                <a:solidFill>
+                  <a:srgbClr val="FFFFFF"/>
+                </a:solidFill>
+              </a14:hiddenFill>
+            </a:ext>
+          </a:extLst>
+        </p:spPr>
+      </p:pic>
+      <p:sp>
+        <p:nvSpPr>
+          <p:cNvPr id="12" name="TextBox 11">
+            <a:extLst>
+              <a:ext uri="{FF2B5EF4-FFF2-40B4-BE49-F238E27FC236}">
+                <a16:creationId xmlns:a16="http://schemas.microsoft.com/office/drawing/2014/main" id="{584786AD-CCA5-50C1-36A3-FA1CB17BCE30}"/>
+              </a:ext>
+            </a:extLst>
+          </p:cNvPr>
+          <p:cNvSpPr txBox="1"/>
+          <p:nvPr/>
+        </p:nvSpPr>
+        <p:spPr>
+          <a:xfrm>
+            <a:off x="9529396" y="6488239"/>
+            <a:ext cx="1666875" cy="369332"/>
+          </a:xfrm>
+          <a:prstGeom prst="rect">
+            <a:avLst/>
+          </a:prstGeom>
+          <a:noFill/>
+        </p:spPr>
+        <p:txBody>
+          <a:bodyPr wrap="square" rtlCol="0">
+            <a:spAutoFit/>
+          </a:bodyPr>
+          <a:lstStyle/>
+          <a:p>
+            <a:r>
+              <a:rPr lang="en-US" dirty="0">
+                <a:solidFill>
+                  <a:schemeClr val="bg1"/>
+                </a:solidFill>
+              </a:rPr>
+              <a:t>Ferris</a:t>
             </a:r>
           </a:p>
         </p:txBody>
@@ -10114,6 +10244,92 @@
           </a:p>
         </p:txBody>
       </p:sp>
+      <p:pic>
+        <p:nvPicPr>
+          <p:cNvPr id="11" name="Picture 2" descr="Rustacean.net: Home of Ferris the Crab">
+            <a:extLst>
+              <a:ext uri="{FF2B5EF4-FFF2-40B4-BE49-F238E27FC236}">
+                <a16:creationId xmlns:a16="http://schemas.microsoft.com/office/drawing/2014/main" id="{CB27A0BB-E25D-C03E-88FC-D089C10585C6}"/>
+              </a:ext>
+            </a:extLst>
+          </p:cNvPr>
+          <p:cNvPicPr>
+            <a:picLocks noChangeAspect="1" noChangeArrowheads="1"/>
+          </p:cNvPicPr>
+          <p:nvPr/>
+        </p:nvPicPr>
+        <p:blipFill>
+          <a:blip r:embed="rId2">
+            <a:extLst>
+              <a:ext uri="{28A0092B-C50C-407E-A947-70E740481C1C}">
+                <a14:useLocalDpi xmlns:a14="http://schemas.microsoft.com/office/drawing/2010/main" val="0"/>
+              </a:ext>
+            </a:extLst>
+          </a:blip>
+          <a:srcRect/>
+          <a:stretch>
+            <a:fillRect/>
+          </a:stretch>
+        </p:blipFill>
+        <p:spPr bwMode="auto">
+          <a:xfrm>
+            <a:off x="3542253" y="5209782"/>
+            <a:ext cx="2040297" cy="1361676"/>
+          </a:xfrm>
+          <a:prstGeom prst="rect">
+            <a:avLst/>
+          </a:prstGeom>
+          <a:noFill/>
+          <a:extLst>
+            <a:ext uri="{909E8E84-426E-40DD-AFC4-6F175D3DCCD1}">
+              <a14:hiddenFill xmlns:a14="http://schemas.microsoft.com/office/drawing/2010/main">
+                <a:solidFill>
+                  <a:srgbClr val="FFFFFF"/>
+                </a:solidFill>
+              </a14:hiddenFill>
+            </a:ext>
+          </a:extLst>
+        </p:spPr>
+      </p:pic>
+      <p:sp>
+        <p:nvSpPr>
+          <p:cNvPr id="12" name="TextBox 11">
+            <a:extLst>
+              <a:ext uri="{FF2B5EF4-FFF2-40B4-BE49-F238E27FC236}">
+                <a16:creationId xmlns:a16="http://schemas.microsoft.com/office/drawing/2014/main" id="{BF2A68A2-154F-F8B1-659D-22E744291858}"/>
+              </a:ext>
+            </a:extLst>
+          </p:cNvPr>
+          <p:cNvSpPr txBox="1"/>
+          <p:nvPr/>
+        </p:nvSpPr>
+        <p:spPr>
+          <a:xfrm>
+            <a:off x="4300232" y="6488668"/>
+            <a:ext cx="1666875" cy="369332"/>
+          </a:xfrm>
+          <a:prstGeom prst="rect">
+            <a:avLst/>
+          </a:prstGeom>
+          <a:noFill/>
+        </p:spPr>
+        <p:txBody>
+          <a:bodyPr wrap="square" rtlCol="0">
+            <a:spAutoFit/>
+          </a:bodyPr>
+          <a:lstStyle/>
+          <a:p>
+            <a:r>
+              <a:rPr lang="en-US" dirty="0">
+                <a:solidFill>
+                  <a:schemeClr val="bg1"/>
+                </a:solidFill>
+              </a:rPr>
+              <a:t>Ferris</a:t>
+            </a:r>
+          </a:p>
+        </p:txBody>
+      </p:sp>
     </p:spTree>
     <p:extLst>
       <p:ext uri="{BB962C8B-B14F-4D97-AF65-F5344CB8AC3E}">
@@ -10600,6 +10816,53 @@
           </a:p>
         </p:txBody>
       </p:sp>
+      <p:pic>
+        <p:nvPicPr>
+          <p:cNvPr id="11" name="Picture 2" descr="Rustacean.net: Home of Ferris the Crab">
+            <a:extLst>
+              <a:ext uri="{FF2B5EF4-FFF2-40B4-BE49-F238E27FC236}">
+                <a16:creationId xmlns:a16="http://schemas.microsoft.com/office/drawing/2014/main" id="{A912C8EF-1C3D-D4AF-AA87-47820666ADC1}"/>
+              </a:ext>
+            </a:extLst>
+          </p:cNvPr>
+          <p:cNvPicPr>
+            <a:picLocks noChangeAspect="1" noChangeArrowheads="1"/>
+          </p:cNvPicPr>
+          <p:nvPr/>
+        </p:nvPicPr>
+        <p:blipFill>
+          <a:blip r:embed="rId2">
+            <a:extLst>
+              <a:ext uri="{28A0092B-C50C-407E-A947-70E740481C1C}">
+                <a14:useLocalDpi xmlns:a14="http://schemas.microsoft.com/office/drawing/2010/main" val="0"/>
+              </a:ext>
+            </a:extLst>
+          </a:blip>
+          <a:srcRect/>
+          <a:stretch>
+            <a:fillRect/>
+          </a:stretch>
+        </p:blipFill>
+        <p:spPr bwMode="auto">
+          <a:xfrm>
+            <a:off x="1584958" y="3295834"/>
+            <a:ext cx="2040297" cy="1361676"/>
+          </a:xfrm>
+          <a:prstGeom prst="rect">
+            <a:avLst/>
+          </a:prstGeom>
+          <a:noFill/>
+          <a:extLst>
+            <a:ext uri="{909E8E84-426E-40DD-AFC4-6F175D3DCCD1}">
+              <a14:hiddenFill xmlns:a14="http://schemas.microsoft.com/office/drawing/2010/main">
+                <a:solidFill>
+                  <a:srgbClr val="FFFFFF"/>
+                </a:solidFill>
+              </a14:hiddenFill>
+            </a:ext>
+          </a:extLst>
+        </p:spPr>
+      </p:pic>
       <p:sp>
         <p:nvSpPr>
           <p:cNvPr id="3" name="Arrow: Up 2">
@@ -10666,6 +10929,9 @@
           <a:prstGeom prst="upArrow">
             <a:avLst/>
           </a:prstGeom>
+          <a:solidFill>
+            <a:schemeClr val="accent1"/>
+          </a:solidFill>
         </p:spPr>
         <p:style>
           <a:lnRef idx="2">
@@ -11430,6 +11696,53 @@
           </a:p>
         </p:txBody>
       </p:sp>
+      <p:pic>
+        <p:nvPicPr>
+          <p:cNvPr id="11" name="Picture 2" descr="Rustacean.net: Home of Ferris the Crab">
+            <a:extLst>
+              <a:ext uri="{FF2B5EF4-FFF2-40B4-BE49-F238E27FC236}">
+                <a16:creationId xmlns:a16="http://schemas.microsoft.com/office/drawing/2014/main" id="{D3950123-1482-65FD-EE0D-65817675B110}"/>
+              </a:ext>
+            </a:extLst>
+          </p:cNvPr>
+          <p:cNvPicPr>
+            <a:picLocks noChangeAspect="1" noChangeArrowheads="1"/>
+          </p:cNvPicPr>
+          <p:nvPr/>
+        </p:nvPicPr>
+        <p:blipFill>
+          <a:blip r:embed="rId2">
+            <a:extLst>
+              <a:ext uri="{28A0092B-C50C-407E-A947-70E740481C1C}">
+                <a14:useLocalDpi xmlns:a14="http://schemas.microsoft.com/office/drawing/2010/main" val="0"/>
+              </a:ext>
+            </a:extLst>
+          </a:blip>
+          <a:srcRect/>
+          <a:stretch>
+            <a:fillRect/>
+          </a:stretch>
+        </p:blipFill>
+        <p:spPr bwMode="auto">
+          <a:xfrm rot="2536809">
+            <a:off x="1008145" y="2881233"/>
+            <a:ext cx="2040297" cy="1361676"/>
+          </a:xfrm>
+          <a:prstGeom prst="rect">
+            <a:avLst/>
+          </a:prstGeom>
+          <a:noFill/>
+          <a:extLst>
+            <a:ext uri="{909E8E84-426E-40DD-AFC4-6F175D3DCCD1}">
+              <a14:hiddenFill xmlns:a14="http://schemas.microsoft.com/office/drawing/2010/main">
+                <a:solidFill>
+                  <a:srgbClr val="FFFFFF"/>
+                </a:solidFill>
+              </a14:hiddenFill>
+            </a:ext>
+          </a:extLst>
+        </p:spPr>
+      </p:pic>
     </p:spTree>
     <p:extLst>
       <p:ext uri="{BB962C8B-B14F-4D97-AF65-F5344CB8AC3E}">
@@ -12118,6 +12431,53 @@
           </a:p>
         </p:txBody>
       </p:sp>
+      <p:pic>
+        <p:nvPicPr>
+          <p:cNvPr id="11" name="Picture 2" descr="Rustacean.net: Home of Ferris the Crab">
+            <a:extLst>
+              <a:ext uri="{FF2B5EF4-FFF2-40B4-BE49-F238E27FC236}">
+                <a16:creationId xmlns:a16="http://schemas.microsoft.com/office/drawing/2014/main" id="{CF7A307E-933F-1570-C599-F92C4778F472}"/>
+              </a:ext>
+            </a:extLst>
+          </p:cNvPr>
+          <p:cNvPicPr>
+            <a:picLocks noChangeAspect="1" noChangeArrowheads="1"/>
+          </p:cNvPicPr>
+          <p:nvPr/>
+        </p:nvPicPr>
+        <p:blipFill>
+          <a:blip r:embed="rId2">
+            <a:extLst>
+              <a:ext uri="{28A0092B-C50C-407E-A947-70E740481C1C}">
+                <a14:useLocalDpi xmlns:a14="http://schemas.microsoft.com/office/drawing/2010/main" val="0"/>
+              </a:ext>
+            </a:extLst>
+          </a:blip>
+          <a:srcRect/>
+          <a:stretch>
+            <a:fillRect/>
+          </a:stretch>
+        </p:blipFill>
+        <p:spPr bwMode="auto">
+          <a:xfrm>
+            <a:off x="735640" y="1055204"/>
+            <a:ext cx="2040297" cy="1361676"/>
+          </a:xfrm>
+          <a:prstGeom prst="rect">
+            <a:avLst/>
+          </a:prstGeom>
+          <a:noFill/>
+          <a:extLst>
+            <a:ext uri="{909E8E84-426E-40DD-AFC4-6F175D3DCCD1}">
+              <a14:hiddenFill xmlns:a14="http://schemas.microsoft.com/office/drawing/2010/main">
+                <a:solidFill>
+                  <a:srgbClr val="FFFFFF"/>
+                </a:solidFill>
+              </a14:hiddenFill>
+            </a:ext>
+          </a:extLst>
+        </p:spPr>
+      </p:pic>
     </p:spTree>
     <p:extLst>
       <p:ext uri="{BB962C8B-B14F-4D97-AF65-F5344CB8AC3E}">

</xml_diff>